<commit_message>
update slides for units XYZ, 7 and 8
</commit_message>
<xml_diff>
--- a/student_files/exercises/Unit_07_GreenHydrogenProduction/Solution.pptx
+++ b/student_files/exercises/Unit_07_GreenHydrogenProduction/Solution.pptx
@@ -751,7 +751,7 @@
           <a:p>
             <a:fld id="{ADE9E86A-6679-4EC8-847C-9F954F45BF68}" type="datetimeFigureOut">
               <a:rPr lang="de-DE" smtClean="0"/>
-              <a:t>18.11.2022</a:t>
+              <a:t>26.03.2025</a:t>
             </a:fld>
             <a:endParaRPr lang="de-DE"/>
           </a:p>
@@ -928,7 +928,7 @@
           <a:p>
             <a:fld id="{E313C419-10E8-4216-A6CC-B7C8A23909AD}" type="datetimeFigureOut">
               <a:rPr lang="de-DE" smtClean="0"/>
-              <a:t>18.11.2022</a:t>
+              <a:t>26.03.2025</a:t>
             </a:fld>
             <a:endParaRPr lang="de-DE"/>
           </a:p>
@@ -3449,32 +3449,20 @@
           <a:p>
             <a:pPr algn="ctr"/>
             <a:r>
-              <a:rPr lang="de-DE" cap="none" dirty="0">
+              <a:rPr lang="de-DE" cap="none">
                 <a:solidFill>
                   <a:prstClr val="white"/>
                 </a:solidFill>
                 <a:cs typeface="Arial" panose="020B0604020202020204" pitchFamily="34" charset="0"/>
               </a:rPr>
-              <a:t>Nov. – </a:t>
+              <a:t>March 2025</a:t>
             </a:r>
-            <a:r>
-              <a:rPr lang="de-DE" cap="none" dirty="0" err="1">
-                <a:solidFill>
-                  <a:prstClr val="white"/>
-                </a:solidFill>
-                <a:cs typeface="Arial" panose="020B0604020202020204" pitchFamily="34" charset="0"/>
-              </a:rPr>
-              <a:t>Dec</a:t>
-            </a:r>
-            <a:r>
-              <a:rPr lang="de-DE" cap="none" dirty="0">
-                <a:solidFill>
-                  <a:prstClr val="white"/>
-                </a:solidFill>
-                <a:cs typeface="Arial" panose="020B0604020202020204" pitchFamily="34" charset="0"/>
-              </a:rPr>
-              <a:t>. 2022</a:t>
-            </a:r>
+            <a:endParaRPr lang="de-DE" cap="none" dirty="0">
+              <a:solidFill>
+                <a:prstClr val="white"/>
+              </a:solidFill>
+              <a:cs typeface="Arial" panose="020B0604020202020204" pitchFamily="34" charset="0"/>
+            </a:endParaRPr>
           </a:p>
           <a:p>
             <a:pPr algn="ctr"/>
@@ -30649,12 +30637,9 @@
 </file>
 
 <file path=customXml/item1.xml><?xml version="1.0" encoding="utf-8"?>
-<?mso-contentType ?>
-<FormTemplates xmlns="http://schemas.microsoft.com/sharepoint/v3/contenttype/forms">
-  <Display>DocumentLibraryForm</Display>
-  <Edit>DocumentLibraryForm</Edit>
-  <New>DocumentLibraryForm</New>
-</FormTemplates>
+<p:properties xmlns:p="http://schemas.microsoft.com/office/2006/metadata/properties" xmlns:xsi="http://www.w3.org/2001/XMLSchema-instance" xmlns:pc="http://schemas.microsoft.com/office/infopath/2007/PartnerControls">
+  <documentManagement/>
+</p:properties>
 </file>
 
 <file path=customXml/item2.xml><?xml version="1.0" encoding="utf-8"?>
@@ -30790,15 +30775,19 @@
 </file>
 
 <file path=customXml/item3.xml><?xml version="1.0" encoding="utf-8"?>
-<p:properties xmlns:p="http://schemas.microsoft.com/office/2006/metadata/properties" xmlns:xsi="http://www.w3.org/2001/XMLSchema-instance" xmlns:pc="http://schemas.microsoft.com/office/infopath/2007/PartnerControls">
-  <documentManagement/>
-</p:properties>
+<?mso-contentType ?>
+<FormTemplates xmlns="http://schemas.microsoft.com/sharepoint/v3/contenttype/forms">
+  <Display>DocumentLibraryForm</Display>
+  <Edit>DocumentLibraryForm</Edit>
+  <New>DocumentLibraryForm</New>
+</FormTemplates>
 </file>
 
 <file path=customXml/itemProps1.xml><?xml version="1.0" encoding="utf-8"?>
-<ds:datastoreItem xmlns:ds="http://schemas.openxmlformats.org/officeDocument/2006/customXml" ds:itemID="{91A508FC-C280-40AD-8398-BAA377701E66}">
+<ds:datastoreItem xmlns:ds="http://schemas.openxmlformats.org/officeDocument/2006/customXml" ds:itemID="{BEBFB196-69DD-47B3-A2FC-0C63F3CA58CB}">
   <ds:schemaRefs>
-    <ds:schemaRef ds:uri="http://schemas.microsoft.com/sharepoint/v3/contenttype/forms"/>
+    <ds:schemaRef ds:uri="http://schemas.microsoft.com/office/2006/metadata/properties"/>
+    <ds:schemaRef ds:uri="http://schemas.microsoft.com/office/infopath/2007/PartnerControls"/>
   </ds:schemaRefs>
 </ds:datastoreItem>
 </file>
@@ -30822,10 +30811,9 @@
 </file>
 
 <file path=customXml/itemProps3.xml><?xml version="1.0" encoding="utf-8"?>
-<ds:datastoreItem xmlns:ds="http://schemas.openxmlformats.org/officeDocument/2006/customXml" ds:itemID="{BEBFB196-69DD-47B3-A2FC-0C63F3CA58CB}">
+<ds:datastoreItem xmlns:ds="http://schemas.openxmlformats.org/officeDocument/2006/customXml" ds:itemID="{91A508FC-C280-40AD-8398-BAA377701E66}">
   <ds:schemaRefs>
-    <ds:schemaRef ds:uri="http://schemas.microsoft.com/office/2006/metadata/properties"/>
-    <ds:schemaRef ds:uri="http://schemas.microsoft.com/office/infopath/2007/PartnerControls"/>
+    <ds:schemaRef ds:uri="http://schemas.microsoft.com/sharepoint/v3/contenttype/forms"/>
   </ds:schemaRefs>
 </ds:datastoreItem>
 </file>
</xml_diff>